<commit_message>
Actualización de portadas al 7 de abril de 2026
</commit_message>
<xml_diff>
--- a/Reporte060426.pptx
+++ b/Reporte060426.pptx
@@ -5,7 +5,7 @@
     <p:sldMasterId id="2147483672" r:id="rId1"/>
   </p:sldMasterIdLst>
   <p:notesMasterIdLst>
-    <p:notesMasterId r:id="rId16"/>
+    <p:notesMasterId r:id="rId15"/>
   </p:notesMasterIdLst>
   <p:sldIdLst>
     <p:sldId id="350" r:id="rId2"/>
@@ -19,32 +19,31 @@
     <p:sldId id="361" r:id="rId10"/>
     <p:sldId id="371" r:id="rId11"/>
     <p:sldId id="370" r:id="rId12"/>
-    <p:sldId id="379" r:id="rId13"/>
-    <p:sldId id="380" r:id="rId14"/>
-    <p:sldId id="280" r:id="rId15"/>
+    <p:sldId id="380" r:id="rId13"/>
+    <p:sldId id="280" r:id="rId14"/>
   </p:sldIdLst>
   <p:sldSz cx="9144000" cy="5143500" type="screen16x9"/>
   <p:notesSz cx="6858000" cy="9144000"/>
   <p:embeddedFontLst>
     <p:embeddedFont>
       <p:font typeface="Montserrat" panose="00000500000000000000" pitchFamily="2" charset="0"/>
-      <p:regular r:id="rId17"/>
-      <p:bold r:id="rId18"/>
-      <p:italic r:id="rId19"/>
-      <p:boldItalic r:id="rId20"/>
+      <p:regular r:id="rId16"/>
+      <p:bold r:id="rId17"/>
+      <p:italic r:id="rId18"/>
+      <p:boldItalic r:id="rId19"/>
     </p:embeddedFont>
     <p:embeddedFont>
       <p:font typeface="Montserrat Black" panose="00000A00000000000000" pitchFamily="2" charset="0"/>
-      <p:bold r:id="rId21"/>
-      <p:italic r:id="rId22"/>
-      <p:boldItalic r:id="rId23"/>
+      <p:bold r:id="rId20"/>
+      <p:italic r:id="rId21"/>
+      <p:boldItalic r:id="rId22"/>
     </p:embeddedFont>
     <p:embeddedFont>
       <p:font typeface="Segoe UI" panose="020B0502040204020203" pitchFamily="34" charset="0"/>
-      <p:regular r:id="rId24"/>
-      <p:bold r:id="rId25"/>
-      <p:italic r:id="rId26"/>
-      <p:boldItalic r:id="rId27"/>
+      <p:regular r:id="rId23"/>
+      <p:bold r:id="rId24"/>
+      <p:italic r:id="rId25"/>
+      <p:boldItalic r:id="rId26"/>
     </p:embeddedFont>
   </p:embeddedFontLst>
   <p:defaultTextStyle>
@@ -6173,10 +6172,10 @@
       </p:sp>
       <p:pic>
         <p:nvPicPr>
-          <p:cNvPr id="3" name="Imagen 2">
+          <p:cNvPr id="4" name="Imagen 3">
             <a:extLst>
               <a:ext uri="{FF2B5EF4-FFF2-40B4-BE49-F238E27FC236}">
-                <a16:creationId xmlns:a16="http://schemas.microsoft.com/office/drawing/2014/main" id="{CD027F35-3A48-6256-BC58-7E83FD96E661}"/>
+                <a16:creationId xmlns:a16="http://schemas.microsoft.com/office/drawing/2014/main" id="{DEFC884C-751E-94CD-94DB-D571B68ECACC}"/>
               </a:ext>
             </a:extLst>
           </p:cNvPr>
@@ -6193,8 +6192,8 @@
         </p:blipFill>
         <p:spPr>
           <a:xfrm>
-            <a:off x="0" y="1230022"/>
-            <a:ext cx="9144000" cy="2683455"/>
+            <a:off x="0" y="1364579"/>
+            <a:ext cx="9144000" cy="2414341"/>
           </a:xfrm>
           <a:prstGeom prst="rect">
             <a:avLst/>
@@ -6271,10 +6270,10 @@
       </p:sp>
       <p:pic>
         <p:nvPicPr>
-          <p:cNvPr id="4" name="Imagen 3">
+          <p:cNvPr id="3" name="Imagen 2">
             <a:extLst>
               <a:ext uri="{FF2B5EF4-FFF2-40B4-BE49-F238E27FC236}">
-                <a16:creationId xmlns:a16="http://schemas.microsoft.com/office/drawing/2014/main" id="{0D5BBB63-1AD2-B0DA-36EC-FD2C9649A63B}"/>
+                <a16:creationId xmlns:a16="http://schemas.microsoft.com/office/drawing/2014/main" id="{AB78AA33-A9D5-A3F6-9481-95BD64E36AD4}"/>
               </a:ext>
             </a:extLst>
           </p:cNvPr>
@@ -6291,8 +6290,8 @@
         </p:blipFill>
         <p:spPr>
           <a:xfrm>
-            <a:off x="0" y="1392535"/>
-            <a:ext cx="9144000" cy="2358430"/>
+            <a:off x="0" y="1351021"/>
+            <a:ext cx="9144000" cy="2441458"/>
           </a:xfrm>
           <a:prstGeom prst="rect">
             <a:avLst/>
@@ -6313,110 +6312,6 @@
 </file>
 
 <file path=ppt/slides/slide12.xml><?xml version="1.0" encoding="utf-8"?>
-<p:sld xmlns:a="http://schemas.openxmlformats.org/drawingml/2006/main" xmlns:r="http://schemas.openxmlformats.org/officeDocument/2006/relationships" xmlns:p="http://schemas.openxmlformats.org/presentationml/2006/main">
-  <p:cSld>
-    <p:spTree>
-      <p:nvGrpSpPr>
-        <p:cNvPr id="1" name="">
-          <a:extLst>
-            <a:ext uri="{FF2B5EF4-FFF2-40B4-BE49-F238E27FC236}">
-              <a16:creationId xmlns:a16="http://schemas.microsoft.com/office/drawing/2014/main" id="{200C1A25-C9EE-F5E8-70B0-72848C49620B}"/>
-            </a:ext>
-          </a:extLst>
-        </p:cNvPr>
-        <p:cNvGrpSpPr/>
-        <p:nvPr/>
-      </p:nvGrpSpPr>
-      <p:grpSpPr>
-        <a:xfrm>
-          <a:off x="0" y="0"/>
-          <a:ext cx="0" cy="0"/>
-          <a:chOff x="0" y="0"/>
-          <a:chExt cx="0" cy="0"/>
-        </a:xfrm>
-      </p:grpSpPr>
-      <p:sp>
-        <p:nvSpPr>
-          <p:cNvPr id="8" name="CuadroTexto 7">
-            <a:extLst>
-              <a:ext uri="{FF2B5EF4-FFF2-40B4-BE49-F238E27FC236}">
-                <a16:creationId xmlns:a16="http://schemas.microsoft.com/office/drawing/2014/main" id="{BD034C7B-D28A-2217-7904-DE5230378964}"/>
-              </a:ext>
-            </a:extLst>
-          </p:cNvPr>
-          <p:cNvSpPr txBox="1"/>
-          <p:nvPr/>
-        </p:nvSpPr>
-        <p:spPr>
-          <a:xfrm>
-            <a:off x="1926166" y="0"/>
-            <a:ext cx="5291667" cy="307777"/>
-          </a:xfrm>
-          <a:prstGeom prst="rect">
-            <a:avLst/>
-          </a:prstGeom>
-          <a:noFill/>
-        </p:spPr>
-        <p:txBody>
-          <a:bodyPr wrap="square" rtlCol="0">
-            <a:spAutoFit/>
-          </a:bodyPr>
-          <a:lstStyle/>
-          <a:p>
-            <a:pPr algn="ctr"/>
-            <a:r>
-              <a:rPr lang="es-MX" b="1" dirty="0">
-                <a:latin typeface="Montserrat" pitchFamily="2" charset="0"/>
-              </a:rPr>
-              <a:t>Temas de gobierno por radiodifusora</a:t>
-            </a:r>
-          </a:p>
-        </p:txBody>
-      </p:sp>
-      <p:pic>
-        <p:nvPicPr>
-          <p:cNvPr id="3" name="Imagen 2">
-            <a:extLst>
-              <a:ext uri="{FF2B5EF4-FFF2-40B4-BE49-F238E27FC236}">
-                <a16:creationId xmlns:a16="http://schemas.microsoft.com/office/drawing/2014/main" id="{7F9FC4D5-ACC1-2E78-F350-8EA7173A6A51}"/>
-              </a:ext>
-            </a:extLst>
-          </p:cNvPr>
-          <p:cNvPicPr>
-            <a:picLocks noChangeAspect="1"/>
-          </p:cNvPicPr>
-          <p:nvPr/>
-        </p:nvPicPr>
-        <p:blipFill>
-          <a:blip r:embed="rId2"/>
-          <a:stretch>
-            <a:fillRect/>
-          </a:stretch>
-        </p:blipFill>
-        <p:spPr>
-          <a:xfrm>
-            <a:off x="0" y="775196"/>
-            <a:ext cx="9144000" cy="3593108"/>
-          </a:xfrm>
-          <a:prstGeom prst="rect">
-            <a:avLst/>
-          </a:prstGeom>
-        </p:spPr>
-      </p:pic>
-    </p:spTree>
-    <p:extLst>
-      <p:ext uri="{BB962C8B-B14F-4D97-AF65-F5344CB8AC3E}">
-        <p14:creationId xmlns:p14="http://schemas.microsoft.com/office/powerpoint/2010/main" val="3986551415"/>
-      </p:ext>
-    </p:extLst>
-  </p:cSld>
-  <p:clrMapOvr>
-    <a:masterClrMapping/>
-  </p:clrMapOvr>
-</p:sld>
-</file>
-
-<file path=ppt/slides/slide13.xml><?xml version="1.0" encoding="utf-8"?>
 <p:sld xmlns:a="http://schemas.openxmlformats.org/drawingml/2006/main" xmlns:r="http://schemas.openxmlformats.org/officeDocument/2006/relationships" xmlns:p="http://schemas.openxmlformats.org/presentationml/2006/main">
   <p:cSld>
     <p:spTree>
@@ -6478,10 +6373,10 @@
       </p:sp>
       <p:pic>
         <p:nvPicPr>
-          <p:cNvPr id="3" name="Imagen 2">
+          <p:cNvPr id="4" name="Imagen 3">
             <a:extLst>
               <a:ext uri="{FF2B5EF4-FFF2-40B4-BE49-F238E27FC236}">
-                <a16:creationId xmlns:a16="http://schemas.microsoft.com/office/drawing/2014/main" id="{E76C2AE5-6278-2571-E9B9-B47ECDDEEB37}"/>
+                <a16:creationId xmlns:a16="http://schemas.microsoft.com/office/drawing/2014/main" id="{B0CDF22D-EB58-BA71-1204-F3559B54EAAC}"/>
               </a:ext>
             </a:extLst>
           </p:cNvPr>
@@ -6498,8 +6393,8 @@
         </p:blipFill>
         <p:spPr>
           <a:xfrm>
-            <a:off x="980574" y="1238064"/>
-            <a:ext cx="7182852" cy="2667372"/>
+            <a:off x="0" y="1711360"/>
+            <a:ext cx="9144000" cy="1720780"/>
           </a:xfrm>
           <a:prstGeom prst="rect">
             <a:avLst/>
@@ -6519,7 +6414,7 @@
 </p:sld>
 </file>
 
-<file path=ppt/slides/slide14.xml><?xml version="1.0" encoding="utf-8"?>
+<file path=ppt/slides/slide13.xml><?xml version="1.0" encoding="utf-8"?>
 <p:sld xmlns:a="http://schemas.openxmlformats.org/drawingml/2006/main" xmlns:r="http://schemas.openxmlformats.org/officeDocument/2006/relationships" xmlns:p="http://schemas.openxmlformats.org/presentationml/2006/main">
   <p:cSld>
     <p:spTree>
@@ -7076,10 +6971,10 @@
       </p:sp>
       <p:pic>
         <p:nvPicPr>
-          <p:cNvPr id="7" name="Imagen 6">
+          <p:cNvPr id="6" name="Imagen 5">
             <a:extLst>
               <a:ext uri="{FF2B5EF4-FFF2-40B4-BE49-F238E27FC236}">
-                <a16:creationId xmlns:a16="http://schemas.microsoft.com/office/drawing/2014/main" id="{25EB97D1-0406-82D5-AB0C-F106718C1792}"/>
+                <a16:creationId xmlns:a16="http://schemas.microsoft.com/office/drawing/2014/main" id="{A328D88E-F7AC-2A68-A018-1591D68BD674}"/>
               </a:ext>
             </a:extLst>
           </p:cNvPr>
@@ -7096,8 +6991,8 @@
         </p:blipFill>
         <p:spPr>
           <a:xfrm>
-            <a:off x="0" y="368923"/>
-            <a:ext cx="9144000" cy="4405654"/>
+            <a:off x="0" y="370887"/>
+            <a:ext cx="9144000" cy="4401725"/>
           </a:xfrm>
           <a:prstGeom prst="rect">
             <a:avLst/>
@@ -7174,10 +7069,10 @@
       </p:sp>
       <p:pic>
         <p:nvPicPr>
-          <p:cNvPr id="3" name="Imagen 2">
+          <p:cNvPr id="7" name="Imagen 6">
             <a:extLst>
               <a:ext uri="{FF2B5EF4-FFF2-40B4-BE49-F238E27FC236}">
-                <a16:creationId xmlns:a16="http://schemas.microsoft.com/office/drawing/2014/main" id="{3AFF2CA9-EA1D-3831-0E70-14EEC4AA8D42}"/>
+                <a16:creationId xmlns:a16="http://schemas.microsoft.com/office/drawing/2014/main" id="{836F7FE1-B4D4-E759-64CB-136040C938F3}"/>
               </a:ext>
             </a:extLst>
           </p:cNvPr>
@@ -7194,8 +7089,8 @@
         </p:blipFill>
         <p:spPr>
           <a:xfrm>
-            <a:off x="0" y="954854"/>
-            <a:ext cx="9144000" cy="3233792"/>
+            <a:off x="0" y="930455"/>
+            <a:ext cx="9144000" cy="3282590"/>
           </a:xfrm>
           <a:prstGeom prst="rect">
             <a:avLst/>
@@ -7278,10 +7173,10 @@
       </p:sp>
       <p:pic>
         <p:nvPicPr>
-          <p:cNvPr id="3" name="Imagen 2">
+          <p:cNvPr id="7" name="Imagen 6">
             <a:extLst>
               <a:ext uri="{FF2B5EF4-FFF2-40B4-BE49-F238E27FC236}">
-                <a16:creationId xmlns:a16="http://schemas.microsoft.com/office/drawing/2014/main" id="{5663E225-0271-8539-B654-7826BA48625D}"/>
+                <a16:creationId xmlns:a16="http://schemas.microsoft.com/office/drawing/2014/main" id="{7DAC338D-1158-A2FA-EBC1-3FCEECD54609}"/>
               </a:ext>
             </a:extLst>
           </p:cNvPr>
@@ -7298,8 +7193,8 @@
         </p:blipFill>
         <p:spPr>
           <a:xfrm>
-            <a:off x="0" y="352948"/>
-            <a:ext cx="9144000" cy="4437604"/>
+            <a:off x="0" y="443809"/>
+            <a:ext cx="9144000" cy="4255882"/>
           </a:xfrm>
           <a:prstGeom prst="rect">
             <a:avLst/>
@@ -7376,10 +7271,10 @@
       </p:sp>
       <p:pic>
         <p:nvPicPr>
-          <p:cNvPr id="4" name="Imagen 3">
+          <p:cNvPr id="7" name="Imagen 6">
             <a:extLst>
               <a:ext uri="{FF2B5EF4-FFF2-40B4-BE49-F238E27FC236}">
-                <a16:creationId xmlns:a16="http://schemas.microsoft.com/office/drawing/2014/main" id="{BA44FF99-E084-8536-CAC7-4677DBF1ED7E}"/>
+                <a16:creationId xmlns:a16="http://schemas.microsoft.com/office/drawing/2014/main" id="{BA8C45B0-4A21-6287-6AFE-B8111BCB1633}"/>
               </a:ext>
             </a:extLst>
           </p:cNvPr>
@@ -7396,8 +7291,8 @@
         </p:blipFill>
         <p:spPr>
           <a:xfrm>
-            <a:off x="0" y="1087698"/>
-            <a:ext cx="9144000" cy="2968103"/>
+            <a:off x="0" y="843433"/>
+            <a:ext cx="9144000" cy="3456633"/>
           </a:xfrm>
           <a:prstGeom prst="rect">
             <a:avLst/>

</xml_diff>